<commit_message>
modify slides to include r^2
</commit_message>
<xml_diff>
--- a/src/16-select-use-assess/Slides.pptx
+++ b/src/16-select-use-assess/Slides.pptx
@@ -108,6 +108,11 @@
       </a:defRPr>
     </a:lvl9pPr>
   </p:defaultTextStyle>
+  <p:extLst>
+    <p:ext uri="{EFAFB233-063F-42B5-8137-9DF3F51BA10A}">
+      <p15:sldGuideLst xmlns:p15="http://schemas.microsoft.com/office/powerpoint/2012/main"/>
+    </p:ext>
+  </p:extLst>
 </p:presentation>
 </file>
 
@@ -561,8 +566,8 @@
             <c:trendlineLbl>
               <c:layout>
                 <c:manualLayout>
-                  <c:x val="0.12974212598425192"/>
-                  <c:y val="0.42550925925925925"/>
+                  <c:x val="0.10751990376202974"/>
+                  <c:y val="0.44865740740740739"/>
                 </c:manualLayout>
               </c:layout>
               <c:tx>
@@ -612,6 +617,22 @@
                         <a:cs typeface="Arial" panose="020B0604020202020204" pitchFamily="34" charset="0"/>
                       </a:rPr>
                       <a:t> + 0.228x + 19.191</a:t>
+                    </a:r>
+                  </a:p>
+                  <a:p>
+                    <a:pPr>
+                      <a:defRPr/>
+                    </a:pPr>
+                    <a:r>
+                      <a:rPr lang="en-US" sz="1200" b="0" i="0" u="none" strike="noStrike" baseline="0" dirty="0">
+                        <a:solidFill>
+                          <a:schemeClr val="tx1"/>
+                        </a:solidFill>
+                        <a:effectLst/>
+                        <a:latin typeface="Arial" panose="020B0604020202020204" pitchFamily="34" charset="0"/>
+                        <a:cs typeface="Arial" panose="020B0604020202020204" pitchFamily="34" charset="0"/>
+                      </a:rPr>
+                      <a:t>R² = 0.9908</a:t>
                     </a:r>
                     <a:endParaRPr lang="en-US" sz="1200" dirty="0">
                       <a:solidFill>
@@ -3993,7 +4014,7 @@
               <c:layout>
                 <c:manualLayout>
                   <c:x val="3.1395013123359579E-2"/>
-                  <c:y val="0.33754629629629629"/>
+                  <c:y val="0.35606481481481483"/>
                 </c:manualLayout>
               </c:layout>
               <c:tx>
@@ -4033,6 +4054,22 @@
                         <a:cs typeface="Arial" panose="020B0604020202020204" pitchFamily="34" charset="0"/>
                       </a:rPr>
                       <a:t>0.0624x</a:t>
+                    </a:r>
+                  </a:p>
+                  <a:p>
+                    <a:pPr>
+                      <a:defRPr/>
+                    </a:pPr>
+                    <a:r>
+                      <a:rPr lang="en-US" sz="1200" b="0" i="0" u="none" strike="noStrike" baseline="0" dirty="0">
+                        <a:solidFill>
+                          <a:schemeClr val="tx1"/>
+                        </a:solidFill>
+                        <a:effectLst/>
+                        <a:latin typeface="Arial" panose="020B0604020202020204" pitchFamily="34" charset="0"/>
+                        <a:cs typeface="Arial" panose="020B0604020202020204" pitchFamily="34" charset="0"/>
+                      </a:rPr>
+                      <a:t>R² = 0.9856</a:t>
                     </a:r>
                     <a:endParaRPr lang="en-US" sz="1200" dirty="0">
                       <a:solidFill>
@@ -14440,7 +14477,7 @@
           <a:p>
             <a:fld id="{B180551C-6A0C-4CBF-8A97-F471076821E3}" type="datetimeFigureOut">
               <a:rPr lang="en-US" smtClean="0"/>
-              <a:t>7/17/2026</a:t>
+              <a:t>7/21/2026</a:t>
             </a:fld>
             <a:endParaRPr lang="en-US"/>
           </a:p>
@@ -14638,7 +14675,7 @@
           <a:p>
             <a:fld id="{B180551C-6A0C-4CBF-8A97-F471076821E3}" type="datetimeFigureOut">
               <a:rPr lang="en-US" smtClean="0"/>
-              <a:t>7/17/2026</a:t>
+              <a:t>7/21/2026</a:t>
             </a:fld>
             <a:endParaRPr lang="en-US"/>
           </a:p>
@@ -14846,7 +14883,7 @@
           <a:p>
             <a:fld id="{B180551C-6A0C-4CBF-8A97-F471076821E3}" type="datetimeFigureOut">
               <a:rPr lang="en-US" smtClean="0"/>
-              <a:t>7/17/2026</a:t>
+              <a:t>7/21/2026</a:t>
             </a:fld>
             <a:endParaRPr lang="en-US"/>
           </a:p>
@@ -15044,7 +15081,7 @@
           <a:p>
             <a:fld id="{B180551C-6A0C-4CBF-8A97-F471076821E3}" type="datetimeFigureOut">
               <a:rPr lang="en-US" smtClean="0"/>
-              <a:t>7/17/2026</a:t>
+              <a:t>7/21/2026</a:t>
             </a:fld>
             <a:endParaRPr lang="en-US"/>
           </a:p>
@@ -15319,7 +15356,7 @@
           <a:p>
             <a:fld id="{B180551C-6A0C-4CBF-8A97-F471076821E3}" type="datetimeFigureOut">
               <a:rPr lang="en-US" smtClean="0"/>
-              <a:t>7/17/2026</a:t>
+              <a:t>7/21/2026</a:t>
             </a:fld>
             <a:endParaRPr lang="en-US"/>
           </a:p>
@@ -15584,7 +15621,7 @@
           <a:p>
             <a:fld id="{B180551C-6A0C-4CBF-8A97-F471076821E3}" type="datetimeFigureOut">
               <a:rPr lang="en-US" smtClean="0"/>
-              <a:t>7/17/2026</a:t>
+              <a:t>7/21/2026</a:t>
             </a:fld>
             <a:endParaRPr lang="en-US"/>
           </a:p>
@@ -15996,7 +16033,7 @@
           <a:p>
             <a:fld id="{B180551C-6A0C-4CBF-8A97-F471076821E3}" type="datetimeFigureOut">
               <a:rPr lang="en-US" smtClean="0"/>
-              <a:t>7/17/2026</a:t>
+              <a:t>7/21/2026</a:t>
             </a:fld>
             <a:endParaRPr lang="en-US"/>
           </a:p>
@@ -16137,7 +16174,7 @@
           <a:p>
             <a:fld id="{B180551C-6A0C-4CBF-8A97-F471076821E3}" type="datetimeFigureOut">
               <a:rPr lang="en-US" smtClean="0"/>
-              <a:t>7/17/2026</a:t>
+              <a:t>7/21/2026</a:t>
             </a:fld>
             <a:endParaRPr lang="en-US"/>
           </a:p>
@@ -16250,7 +16287,7 @@
           <a:p>
             <a:fld id="{B180551C-6A0C-4CBF-8A97-F471076821E3}" type="datetimeFigureOut">
               <a:rPr lang="en-US" smtClean="0"/>
-              <a:t>7/17/2026</a:t>
+              <a:t>7/21/2026</a:t>
             </a:fld>
             <a:endParaRPr lang="en-US"/>
           </a:p>
@@ -16561,7 +16598,7 @@
           <a:p>
             <a:fld id="{B180551C-6A0C-4CBF-8A97-F471076821E3}" type="datetimeFigureOut">
               <a:rPr lang="en-US" smtClean="0"/>
-              <a:t>7/17/2026</a:t>
+              <a:t>7/21/2026</a:t>
             </a:fld>
             <a:endParaRPr lang="en-US"/>
           </a:p>
@@ -16849,7 +16886,7 @@
           <a:p>
             <a:fld id="{B180551C-6A0C-4CBF-8A97-F471076821E3}" type="datetimeFigureOut">
               <a:rPr lang="en-US" smtClean="0"/>
-              <a:t>7/17/2026</a:t>
+              <a:t>7/21/2026</a:t>
             </a:fld>
             <a:endParaRPr lang="en-US"/>
           </a:p>
@@ -17090,7 +17127,7 @@
           <a:p>
             <a:fld id="{B180551C-6A0C-4CBF-8A97-F471076821E3}" type="datetimeFigureOut">
               <a:rPr lang="en-US" smtClean="0"/>
-              <a:t>7/17/2026</a:t>
+              <a:t>7/21/2026</a:t>
             </a:fld>
             <a:endParaRPr lang="en-US"/>
           </a:p>
@@ -17528,7 +17565,7 @@
           <p:nvPr>
             <p:extLst>
               <p:ext uri="{D42A27DB-BD31-4B8C-83A1-F6EECF244321}">
-                <p14:modId xmlns:p14="http://schemas.microsoft.com/office/powerpoint/2010/main" val="1306407027"/>
+                <p14:modId xmlns:p14="http://schemas.microsoft.com/office/powerpoint/2010/main" val="2591949651"/>
               </p:ext>
             </p:extLst>
           </p:nvPr>
@@ -17558,7 +17595,7 @@
           <p:nvPr>
             <p:extLst>
               <p:ext uri="{D42A27DB-BD31-4B8C-83A1-F6EECF244321}">
-                <p14:modId xmlns:p14="http://schemas.microsoft.com/office/powerpoint/2010/main" val="34995074"/>
+                <p14:modId xmlns:p14="http://schemas.microsoft.com/office/powerpoint/2010/main" val="2231792921"/>
               </p:ext>
             </p:extLst>
           </p:nvPr>
@@ -18191,7 +18228,7 @@
         <p:spPr>
           <a:xfrm>
             <a:off x="7772400" y="5601454"/>
-            <a:ext cx="6096000" cy="276999"/>
+            <a:ext cx="6096000" cy="461665"/>
           </a:xfrm>
           <a:prstGeom prst="rect">
             <a:avLst/>
@@ -18261,6 +18298,35 @@
               <a:t>cos(2πx/60)</a:t>
             </a:r>
           </a:p>
+          <a:p>
+            <a:pPr algn="ctr"/>
+            <a:r>
+              <a:rPr lang="en-US" sz="1200" dirty="0">
+                <a:solidFill>
+                  <a:srgbClr val="000000"/>
+                </a:solidFill>
+                <a:latin typeface="Calibri" panose="020F0502020204030204" pitchFamily="34" charset="0"/>
+              </a:rPr>
+              <a:t>R</a:t>
+            </a:r>
+            <a:r>
+              <a:rPr lang="en-US" sz="1200" dirty="0">
+                <a:latin typeface="Arial" panose="020B0604020202020204" pitchFamily="34" charset="0"/>
+                <a:cs typeface="Arial" panose="020B0604020202020204" pitchFamily="34" charset="0"/>
+              </a:rPr>
+              <a:t>²</a:t>
+            </a:r>
+            <a:r>
+              <a:rPr lang="en-US" sz="1200" dirty="0">
+                <a:solidFill>
+                  <a:srgbClr val="000000"/>
+                </a:solidFill>
+                <a:latin typeface="Calibri" panose="020F0502020204030204" pitchFamily="34" charset="0"/>
+              </a:rPr>
+              <a:t> = 0.99653212</a:t>
+            </a:r>
+            <a:endParaRPr lang="en-US" sz="1200" dirty="0"/>
+          </a:p>
         </p:txBody>
       </p:sp>
       <p:sp>
@@ -18278,7 +18344,7 @@
         <p:spPr>
           <a:xfrm>
             <a:off x="1219200" y="5601454"/>
-            <a:ext cx="3566160" cy="276999"/>
+            <a:ext cx="3566160" cy="461665"/>
           </a:xfrm>
           <a:prstGeom prst="rect">
             <a:avLst/>
@@ -18481,17 +18547,35 @@
                 <a:latin typeface="Arial" panose="020B0604020202020204" pitchFamily="34" charset="0"/>
                 <a:cs typeface="Arial" panose="020B0604020202020204" pitchFamily="34" charset="0"/>
               </a:rPr>
-              <a:t> + </a:t>
+              <a:t> + I</a:t>
+            </a:r>
+          </a:p>
+          <a:p>
+            <a:pPr algn="ctr"/>
+            <a:r>
+              <a:rPr lang="en-US" sz="1200" dirty="0">
+                <a:solidFill>
+                  <a:srgbClr val="000000"/>
+                </a:solidFill>
+                <a:latin typeface="Calibri" panose="020F0502020204030204" pitchFamily="34" charset="0"/>
+              </a:rPr>
+              <a:t>R</a:t>
             </a:r>
             <a:r>
-              <a:rPr lang="en-US" sz="1200" baseline="0" dirty="0" err="1">
-                <a:solidFill>
-                  <a:schemeClr val="tx1"/>
-                </a:solidFill>
+              <a:rPr lang="en-US" sz="1200" dirty="0">
                 <a:latin typeface="Arial" panose="020B0604020202020204" pitchFamily="34" charset="0"/>
                 <a:cs typeface="Arial" panose="020B0604020202020204" pitchFamily="34" charset="0"/>
               </a:rPr>
-              <a:t>i</a:t>
+              <a:t>²</a:t>
+            </a:r>
+            <a:r>
+              <a:rPr lang="en-US" sz="1200" dirty="0">
+                <a:solidFill>
+                  <a:srgbClr val="000000"/>
+                </a:solidFill>
+                <a:latin typeface="Calibri" panose="020F0502020204030204" pitchFamily="34" charset="0"/>
+              </a:rPr>
+              <a:t> = 0.99762</a:t>
             </a:r>
             <a:endParaRPr lang="en-US" sz="1200" dirty="0"/>
           </a:p>

</xml_diff>